<commit_message>
Finalize team name and refreshed demo evidence
</commit_message>
<xml_diff>
--- a/slides/PRESENTATION_DECK.pptx
+++ b/slides/PRESENTATION_DECK.pptx
@@ -3787,7 +3787,7 @@
               <a:defRPr sz="2000"/>
             </a:pPr>
             <a:r>
-              <a:t>Team [TEAM NAME] · all execution SIMULATED in a sandbox</a:t>
+              <a:t>Team TuitionBridge FinTech Lab · all execution SIMULATED in a sandbox</a:t>
             </a:r>
           </a:p>
         </p:txBody>
@@ -3847,8 +3847,8 @@
         </p:blipFill>
         <p:spPr>
           <a:xfrm>
-            <a:off x="4238808" y="1280160"/>
-            <a:ext cx="3714079" cy="5120640"/>
+            <a:off x="4429425" y="1280160"/>
+            <a:ext cx="3332844" cy="5120640"/>
           </a:xfrm>
           <a:prstGeom prst="rect">
             <a:avLst/>

</xml_diff>